<commit_message>
Honest content: remove all aspirational stats - position as early stage seeking validation
</commit_message>
<xml_diff>
--- a/SebilAI_PitchDeck.pptx
+++ b/SebilAI_PitchDeck.pptx
@@ -1944,7 +1944,7 @@
                   <a:srgbClr val="B8DC7A"/>
                 </a:solidFill>
               </a:rPr>
-              <a:t>87%</a:t>
+              <a:t>23+</a:t>
             </a:r>
             <a:endParaRPr lang="en-US" sz="1300" dirty="0"/>
           </a:p>
@@ -1980,7 +1980,7 @@
                   <a:srgbClr val="99CC66"/>
                 </a:solidFill>
               </a:rPr>
-              <a:t>Accuracy</a:t>
+              <a:t>Studies</a:t>
             </a:r>
             <a:endParaRPr lang="en-US" sz="800" dirty="0"/>
           </a:p>
@@ -2142,7 +2142,7 @@
                   <a:srgbClr val="B8DC7A"/>
                 </a:solidFill>
               </a:rPr>
-              <a:t>1,247+</a:t>
+              <a:t>42</a:t>
             </a:r>
             <a:endParaRPr lang="en-US" sz="1300" dirty="0"/>
           </a:p>
@@ -2178,7 +2178,7 @@
                   <a:srgbClr val="99CC66"/>
                 </a:solidFill>
               </a:rPr>
-              <a:t>Diagnoses</a:t>
+              <a:t>Diseases</a:t>
             </a:r>
             <a:endParaRPr lang="en-US" sz="800" dirty="0"/>
           </a:p>
@@ -2241,7 +2241,7 @@
                   <a:srgbClr val="B8DC7A"/>
                 </a:solidFill>
               </a:rPr>
-              <a:t>42</a:t>
+              <a:t>8</a:t>
             </a:r>
             <a:endParaRPr lang="en-US" sz="1300" dirty="0"/>
           </a:p>
@@ -2277,7 +2277,7 @@
                   <a:srgbClr val="99CC66"/>
                 </a:solidFill>
               </a:rPr>
-              <a:t>Diseases</a:t>
+              <a:t>Crops</a:t>
             </a:r>
             <a:endParaRPr lang="en-US" sz="800" dirty="0"/>
           </a:p>
@@ -2376,7 +2376,7 @@
                   <a:srgbClr val="99CC66"/>
                 </a:solidFill>
               </a:rPr>
-              <a:t>Always</a:t>
+              <a:t>Forever</a:t>
             </a:r>
             <a:endParaRPr lang="en-US" sz="800" dirty="0"/>
           </a:p>
@@ -6683,7 +6683,7 @@
                   <a:srgbClr val="FFFFFF"/>
                 </a:solidFill>
               </a:rPr>
-              <a:t>VALIDATION</a:t>
+              <a:t>OUR FOUNDATION</a:t>
             </a:r>
             <a:endParaRPr lang="en-US" sz="800" dirty="0"/>
           </a:p>
@@ -6719,7 +6719,7 @@
                   <a:srgbClr val="FFFFFF"/>
                 </a:solidFill>
               </a:rPr>
-              <a:t>Real Numbers. Real Farmers. Real Ethiopia.</a:t>
+              <a:t>Built on Ethiopian Research. Seeking Validation Partners.</a:t>
             </a:r>
             <a:endParaRPr lang="en-US" sz="2400" dirty="0"/>
           </a:p>
@@ -6807,7 +6807,7 @@
                   <a:srgbClr val="2D6A0A"/>
                 </a:solidFill>
               </a:rPr>
-              <a:t>87%</a:t>
+              <a:t>23+</a:t>
             </a:r>
             <a:endParaRPr lang="en-US" sz="2800" dirty="0"/>
           </a:p>
@@ -6843,7 +6843,7 @@
                   <a:srgbClr val="4A3728"/>
                 </a:solidFill>
               </a:rPr>
-              <a:t>Agronomist</a:t>
+              <a:t>Ethiopian Research</a:t>
             </a:r>
             <a:endParaRPr lang="en-US" sz="800" dirty="0"/>
           </a:p>
@@ -6857,7 +6857,7 @@
                   <a:srgbClr val="4A3728"/>
                 </a:solidFill>
               </a:rPr>
-              <a:t>Agreement</a:t>
+              <a:t>Papers in Core</a:t>
             </a:r>
             <a:endParaRPr lang="en-US" sz="800" dirty="0"/>
           </a:p>
@@ -6871,7 +6871,7 @@
                   <a:srgbClr val="4A3728"/>
                 </a:solidFill>
               </a:rPr>
-              <a:t>(n=120)</a:t>
+              <a:t>Knowledge Base</a:t>
             </a:r>
             <a:endParaRPr lang="en-US" sz="800" dirty="0"/>
           </a:p>
@@ -6959,7 +6959,7 @@
                   <a:srgbClr val="4A8F1F"/>
                 </a:solidFill>
               </a:rPr>
-              <a:t>42%</a:t>
+              <a:t>42</a:t>
             </a:r>
             <a:endParaRPr lang="en-US" sz="2800" dirty="0"/>
           </a:p>
@@ -6995,7 +6995,7 @@
                   <a:srgbClr val="4A3728"/>
                 </a:solidFill>
               </a:rPr>
-              <a:t>Avg Yield</a:t>
+              <a:t>Diseases Across</a:t>
             </a:r>
             <a:endParaRPr lang="en-US" sz="800" dirty="0"/>
           </a:p>
@@ -7009,7 +7009,7 @@
                   <a:srgbClr val="4A3728"/>
                 </a:solidFill>
               </a:rPr>
-              <a:t>Loss Reduced</a:t>
+              <a:t>8 Ethiopian Crops</a:t>
             </a:r>
             <a:endParaRPr lang="en-US" sz="800" dirty="0"/>
           </a:p>
@@ -7097,7 +7097,7 @@
                   <a:srgbClr val="1A6B5A"/>
                 </a:solidFill>
               </a:rPr>
-              <a:t>1,247+</a:t>
+              <a:t>6</a:t>
             </a:r>
             <a:endParaRPr lang="en-US" sz="2800" dirty="0"/>
           </a:p>
@@ -7133,7 +7133,7 @@
                   <a:srgbClr val="4A3728"/>
                 </a:solidFill>
               </a:rPr>
-              <a:t>Total Diagnoses</a:t>
+              <a:t>Ethiopian Languages</a:t>
             </a:r>
             <a:endParaRPr lang="en-US" sz="800" dirty="0"/>
           </a:p>
@@ -7147,7 +7147,7 @@
                   <a:srgbClr val="4A3728"/>
                 </a:solidFill>
               </a:rPr>
-              <a:t>Made</a:t>
+              <a:t>Fully Translated</a:t>
             </a:r>
             <a:endParaRPr lang="en-US" sz="800" dirty="0"/>
           </a:p>
@@ -7235,7 +7235,7 @@
                   <a:srgbClr val="8B6914"/>
                 </a:solidFill>
               </a:rPr>
-              <a:t>6</a:t>
+              <a:t>100%</a:t>
             </a:r>
             <a:endParaRPr lang="en-US" sz="2800" dirty="0"/>
           </a:p>
@@ -7271,7 +7271,7 @@
                   <a:srgbClr val="4A3728"/>
                 </a:solidFill>
               </a:rPr>
-              <a:t>Ethiopian</a:t>
+              <a:t>Offline Capable</a:t>
             </a:r>
             <a:endParaRPr lang="en-US" sz="800" dirty="0"/>
           </a:p>
@@ -7285,7 +7285,7 @@
                   <a:srgbClr val="4A3728"/>
                 </a:solidFill>
               </a:rPr>
-              <a:t>Languages</a:t>
+              <a:t>(No Internet Needed)</a:t>
             </a:r>
             <a:endParaRPr lang="en-US" sz="800" dirty="0"/>
           </a:p>
@@ -8848,7 +8848,7 @@
                   <a:srgbClr val="888888"/>
                 </a:solidFill>
               </a:rPr>
-              <a:t>Pilot: Oromia | SNNPR | Amhara  |  May 2025-May 2026  |  120 field validations  |  8 crops  |  23+ Ethiopian studies</a:t>
+              <a:t>Built on 23+ Ethiopian peer-reviewed papers (EIAR, Hawassa University, Jimma, Werabe ARC). Early-stage — actively seeking field validation partners.</a:t>
             </a:r>
             <a:endParaRPr lang="en-US" sz="750" dirty="0"/>
           </a:p>
@@ -13308,7 +13308,7 @@
                   <a:srgbClr val="FFFFFF"/>
                 </a:solidFill>
               </a:rPr>
-              <a:t>87%</a:t>
+              <a:t>RES</a:t>
             </a:r>
             <a:endParaRPr lang="en-US" sz="1000" dirty="0"/>
           </a:p>
@@ -13344,7 +13344,7 @@
                   <a:srgbClr val="B8DC7A"/>
                 </a:solidFill>
               </a:rPr>
-              <a:t>Validated</a:t>
+              <a:t>Research-Grounded</a:t>
             </a:r>
             <a:endParaRPr lang="en-US" sz="1200" dirty="0"/>
           </a:p>
@@ -13380,7 +13380,7 @@
                   <a:srgbClr val="FFFFFF"/>
                 </a:solidFill>
               </a:rPr>
-              <a:t>87% agronomist agreement  |  n=120  |  1,247+ real diagnoses to date</a:t>
+              <a:t>23+ Ethiopian papers (EIAR, Hawassa, Jimma, Werabe ARC) — full citations available</a:t>
             </a:r>
             <a:endParaRPr lang="en-US" sz="1050" dirty="0"/>
           </a:p>

</xml_diff>